<commit_message>
feat: update README and presentation materials with new data and insights; enhance live.js and collection.js for better vehicle tracking and display
</commit_message>
<xml_diff>
--- a/presentation/Cascais_Sweep.pptx
+++ b/presentation/Cascais_Sweep.pptx
@@ -1265,7 +1265,7 @@
           <a:p>
             <a:r>
               <a:rPr lang="en-US" dirty="0"/>
-              <a:t>In Cascais, a scooter left more than 30 metres from a station for over 2 hours is abandoned, and the municipality has to collect it. We analysed three weeks of Bird data: 44 new abandoned vehicles every day, and the typical one stays on the street for another 13 and a half hours. Today the city team makes one 2-hour run and collects about 10.</a:t>
+              <a:t>In Cascais, a scooter left more than 30 metres from a station for over 2 hours is abandoned, and the municipality has to collect it. We analysed three weeks of Bird data: 44 new abandoned vehicles every day, and the typical one stays on the street for another 13 and a half hours. In our data period the city team made one 2-hour run a day and collected about 10.</a:t>
             </a:r>
             <a:endParaRPr lang="en-US" dirty="0"/>
           </a:p>
@@ -2514,8 +2514,8 @@
         </p:nvSpPr>
         <p:spPr>
           <a:xfrm>
-            <a:off x="548640" y="1005840"/>
-            <a:ext cx="8046720" cy="457200"/>
+            <a:off x="548640" y="960120"/>
+            <a:ext cx="8046720" cy="640080"/>
           </a:xfrm>
           <a:prstGeom prst="rect">
             <a:avLst/>
@@ -2531,7 +2531,7 @@
               <a:buNone/>
             </a:pPr>
             <a:r>
-              <a:rPr lang="en-US" sz="1500" dirty="0">
+              <a:rPr lang="en-US" sz="1400" dirty="0">
                 <a:solidFill>
                   <a:srgbClr val="52514E"/>
                 </a:solidFill>
@@ -2539,9 +2539,9 @@
                 <a:ea typeface="Calibri" pitchFamily="34" charset="-122"/>
                 <a:cs typeface="Calibri" pitchFamily="34" charset="-120"/>
               </a:rPr>
-              <a:t>A scooter left &gt; 30 m from a station for &gt; 2 h must be collected by the municipality. 3 weeks of Bird data:</a:t>
-            </a:r>
-            <a:endParaRPr lang="en-US" sz="1500" dirty="0"/>
+              <a:t>Bird (private operator) must keep its scooters at stations. If one stays &gt; 30 m outside for &gt; 2 h, Cascais Próxima (the city) removes it and Bird pays a €4.5 fine. 3 weeks of Bird data:</a:t>
+            </a:r>
+            <a:endParaRPr lang="en-US" sz="1400" dirty="0"/>
           </a:p>
         </p:txBody>
       </p:sp>
@@ -2553,12 +2553,12 @@
         </p:nvSpPr>
         <p:spPr>
           <a:xfrm>
-            <a:off x="548640" y="1737360"/>
-            <a:ext cx="2468880" cy="2286000"/>
+            <a:off x="548640" y="1783080"/>
+            <a:ext cx="2468880" cy="2240280"/>
           </a:xfrm>
           <a:prstGeom prst="roundRect">
             <a:avLst>
-              <a:gd name="adj" fmla="val 4800"/>
+              <a:gd name="adj" fmla="val 4898"/>
             </a:avLst>
           </a:prstGeom>
           <a:solidFill>
@@ -2580,7 +2580,7 @@
         </p:nvSpPr>
         <p:spPr>
           <a:xfrm>
-            <a:off x="777240" y="1965960"/>
+            <a:off x="777240" y="2011680"/>
             <a:ext cx="2011680" cy="914400"/>
           </a:xfrm>
           <a:prstGeom prst="rect">
@@ -2675,12 +2675,12 @@
         </p:nvSpPr>
         <p:spPr>
           <a:xfrm>
-            <a:off x="3291840" y="1737360"/>
-            <a:ext cx="2468880" cy="2286000"/>
+            <a:off x="3291840" y="1783080"/>
+            <a:ext cx="2468880" cy="2240280"/>
           </a:xfrm>
           <a:prstGeom prst="roundRect">
             <a:avLst>
-              <a:gd name="adj" fmla="val 4800"/>
+              <a:gd name="adj" fmla="val 4898"/>
             </a:avLst>
           </a:prstGeom>
           <a:solidFill>
@@ -2702,7 +2702,7 @@
         </p:nvSpPr>
         <p:spPr>
           <a:xfrm>
-            <a:off x="3520440" y="1965960"/>
+            <a:off x="3520440" y="2011680"/>
             <a:ext cx="2011680" cy="914400"/>
           </a:xfrm>
           <a:prstGeom prst="rect">
@@ -2797,12 +2797,12 @@
         </p:nvSpPr>
         <p:spPr>
           <a:xfrm>
-            <a:off x="6035040" y="1737360"/>
-            <a:ext cx="2468880" cy="2286000"/>
+            <a:off x="6035040" y="1783080"/>
+            <a:ext cx="2468880" cy="2240280"/>
           </a:xfrm>
           <a:prstGeom prst="roundRect">
             <a:avLst>
-              <a:gd name="adj" fmla="val 4800"/>
+              <a:gd name="adj" fmla="val 4898"/>
             </a:avLst>
           </a:prstGeom>
           <a:solidFill>
@@ -2824,7 +2824,7 @@
         </p:nvSpPr>
         <p:spPr>
           <a:xfrm>
-            <a:off x="6263640" y="1965960"/>
+            <a:off x="6263640" y="2011680"/>
             <a:ext cx="2011680" cy="914400"/>
           </a:xfrm>
           <a:prstGeom prst="rect">
@@ -2849,7 +2849,7 @@
                 <a:ea typeface="Calibri" pitchFamily="34" charset="-122"/>
                 <a:cs typeface="Calibri" pitchFamily="34" charset="-120"/>
               </a:rPr>
-              <a:t>1 run</a:t>
+              <a:t>~10</a:t>
             </a:r>
             <a:endParaRPr lang="en-US" sz="5400" dirty="0"/>
           </a:p>
@@ -2888,7 +2888,7 @@
                 <a:ea typeface="Calibri" pitchFamily="34" charset="-122"/>
                 <a:cs typeface="Calibri" pitchFamily="34" charset="-120"/>
               </a:rPr>
-              <a:t>of ~2 h a day today,</a:t>
+              <a:t>collected by the city per day</a:t>
             </a:r>
             <a:endParaRPr lang="en-US" sz="1400" dirty="0"/>
           </a:p>
@@ -2905,7 +2905,7 @@
                 <a:ea typeface="Calibri" pitchFamily="34" charset="-122"/>
                 <a:cs typeface="Calibri" pitchFamily="34" charset="-120"/>
               </a:rPr>
-              <a:t>~10 vehicles collected</a:t>
+              <a:t>in our data period (one run)</a:t>
             </a:r>
             <a:endParaRPr lang="en-US" sz="1400" dirty="0"/>
           </a:p>
@@ -3357,7 +3357,7 @@
                 <a:ea typeface="Calibri" pitchFamily="34" charset="-122"/>
                 <a:cs typeface="Calibri" pitchFamily="34" charset="-120"/>
               </a:rPr>
-              <a:t>The city and the operator</a:t>
+              <a:t>The city vs the operator</a:t>
             </a:r>
             <a:endParaRPr lang="en-US" sz="1800" dirty="0"/>
           </a:p>
@@ -3396,7 +3396,7 @@
                 <a:ea typeface="Calibri" pitchFamily="34" charset="-122"/>
                 <a:cs typeface="Calibri" pitchFamily="34" charset="-120"/>
               </a:rPr>
-              <a:t>Every collected vehicle is a €4.5 fine for Bird — a reason for the operator to clear its own fleet.</a:t>
+              <a:t>Two different organisations: Bird earns from rides, the city keeps the streets clear. Every scooter the city removes costs Bird €4.5.</a:t>
             </a:r>
             <a:endParaRPr lang="en-US" sz="1400" dirty="0"/>
           </a:p>
@@ -3435,7 +3435,7 @@
                 <a:ea typeface="Calibri" pitchFamily="34" charset="-122"/>
                 <a:cs typeface="Calibri" pitchFamily="34" charset="-120"/>
               </a:rPr>
-              <a:t>Rules designed with João Silva, Cascais Próxima: depot, van capacity, today's workflow, the fine.</a:t>
+              <a:t>Rules designed with João Silva, Cascais Próxima: depot, van capacity, how the team works, the fine.</a:t>
             </a:r>
             <a:endParaRPr lang="en-US" sz="1100" dirty="0"/>
           </a:p>
@@ -4911,7 +4911,7 @@
                 <a:ea typeface="Calibri" pitchFamily="34" charset="-122"/>
                 <a:cs typeface="Calibri" pitchFamily="34" charset="-120"/>
               </a:rPr>
-              <a:t>instead of ~10 today</a:t>
+              <a:t>instead of ~10 in our data</a:t>
             </a:r>
             <a:endParaRPr lang="en-US" sz="1200" dirty="0"/>
           </a:p>
@@ -5194,7 +5194,7 @@
                 <a:ea typeface="Calibri" pitchFamily="34" charset="-122"/>
                 <a:cs typeface="Calibri" pitchFamily="34" charset="-120"/>
               </a:rPr>
-              <a:t>Same 2-hour run as today: 12.7 vehicles instead of ~10. Vehicles at bus stops collected first.</a:t>
+              <a:t>In one 2-hour run: 12.7 vehicles instead of ~10. Vehicles at bus stops collected first.</a:t>
             </a:r>
             <a:endParaRPr lang="en-US" sz="1100" dirty="0"/>
           </a:p>

</xml_diff>